<commit_message>
Completion of All Features
</commit_message>
<xml_diff>
--- a/A-D2.pptx
+++ b/A-D2.pptx
@@ -6,7 +6,7 @@
     <p:sldMasterId id="2147483660" r:id="rId2"/>
   </p:sldMasterIdLst>
   <p:notesMasterIdLst>
-    <p:notesMasterId r:id="rId12"/>
+    <p:notesMasterId r:id="rId13"/>
   </p:notesMasterIdLst>
   <p:sldIdLst>
     <p:sldId id="273" r:id="rId3"/>
@@ -17,7 +17,8 @@
     <p:sldId id="293" r:id="rId8"/>
     <p:sldId id="289" r:id="rId9"/>
     <p:sldId id="291" r:id="rId10"/>
-    <p:sldId id="286" r:id="rId11"/>
+    <p:sldId id="294" r:id="rId11"/>
+    <p:sldId id="286" r:id="rId12"/>
   </p:sldIdLst>
   <p:sldSz cx="9144000" cy="6858000" type="screen4x3"/>
   <p:notesSz cx="7772400" cy="10058400"/>
@@ -8952,7 +8953,7 @@
 </p:sld>
 </file>
 
-<file path=ppt/slides/slide2.xml><?xml version="1.0" encoding="utf-8"?>
+<file path=ppt/slides/slide10.xml><?xml version="1.0" encoding="utf-8"?>
 <p:sld xmlns:a="http://schemas.openxmlformats.org/drawingml/2006/main" xmlns:r="http://schemas.openxmlformats.org/officeDocument/2006/relationships" xmlns:p="http://schemas.openxmlformats.org/presentationml/2006/main">
   <p:cSld>
     <p:spTree>
@@ -8971,7 +8972,7 @@
       </p:grpSpPr>
       <p:sp>
         <p:nvSpPr>
-          <p:cNvPr id="4098" name="object 5"/>
+          <p:cNvPr id="5122" name="object 5"/>
           <p:cNvSpPr>
             <a:spLocks/>
           </p:cNvSpPr>
@@ -9087,7 +9088,7 @@
         <p:spPr bwMode="auto">
           <a:xfrm>
             <a:off x="303213" y="1336675"/>
-            <a:ext cx="8662987" cy="398463"/>
+            <a:ext cx="8662987" cy="1014203"/>
           </a:xfrm>
           <a:prstGeom prst="rect">
             <a:avLst/>
@@ -9276,14 +9277,778 @@
               <a:buNone/>
             </a:pPr>
             <a:r>
-              <a:rPr lang="en-US" altLang="en-US" sz="2000">
+              <a:rPr lang="en-US" altLang="en-US" sz="2000" dirty="0">
                 <a:solidFill>
                   <a:srgbClr val="1C1C1C"/>
                 </a:solidFill>
                 <a:latin typeface="Tahoma" pitchFamily="34" charset="0"/>
                 <a:cs typeface="Tahoma" pitchFamily="34" charset="0"/>
               </a:rPr>
-              <a:t>Add Items</a:t>
+              <a:t>In conclusion, the central banking expert system was improved significantly by including certainty factors and fuzziness, as well as by supporting various quality attributes.</a:t>
+            </a:r>
+          </a:p>
+        </p:txBody>
+      </p:sp>
+      <p:sp>
+        <p:nvSpPr>
+          <p:cNvPr id="5124" name="object 7"/>
+          <p:cNvSpPr txBox="1">
+            <a:spLocks noChangeArrowheads="1"/>
+          </p:cNvSpPr>
+          <p:nvPr/>
+        </p:nvSpPr>
+        <p:spPr bwMode="auto">
+          <a:xfrm>
+            <a:off x="588963" y="238125"/>
+            <a:ext cx="8091487" cy="554038"/>
+          </a:xfrm>
+          <a:prstGeom prst="rect">
+            <a:avLst/>
+          </a:prstGeom>
+          <a:noFill/>
+          <a:ln>
+            <a:noFill/>
+          </a:ln>
+          <a:extLst>
+            <a:ext uri="{909E8E84-426E-40DD-AFC4-6F175D3DCCD1}">
+              <a14:hiddenFill xmlns:a14="http://schemas.microsoft.com/office/drawing/2010/main">
+                <a:solidFill>
+                  <a:srgbClr val="FFFFFF"/>
+                </a:solidFill>
+              </a14:hiddenFill>
+            </a:ext>
+            <a:ext uri="{91240B29-F687-4F45-9708-019B960494DF}">
+              <a14:hiddenLine xmlns:a14="http://schemas.microsoft.com/office/drawing/2010/main" w="9525">
+                <a:solidFill>
+                  <a:srgbClr val="000000"/>
+                </a:solidFill>
+                <a:miter lim="800000"/>
+                <a:headEnd/>
+                <a:tailEnd/>
+              </a14:hiddenLine>
+            </a:ext>
+          </a:extLst>
+        </p:spPr>
+        <p:txBody>
+          <a:bodyPr lIns="0" tIns="0" rIns="0" bIns="0" anchorCtr="1">
+            <a:spAutoFit/>
+          </a:bodyPr>
+          <a:lstStyle>
+            <a:lvl1pPr marL="11113">
+              <a:spcAft>
+                <a:spcPts val="1413"/>
+              </a:spcAft>
+              <a:buChar char="•"/>
+              <a:defRPr sz="2400">
+                <a:solidFill>
+                  <a:srgbClr val="000000"/>
+                </a:solidFill>
+                <a:latin typeface="Times New Roman" pitchFamily="18" charset="0"/>
+                <a:ea typeface="Microsoft YaHei" pitchFamily="34" charset="-122"/>
+              </a:defRPr>
+            </a:lvl1pPr>
+            <a:lvl2pPr marL="685800" indent="-228600">
+              <a:spcAft>
+                <a:spcPts val="1413"/>
+              </a:spcAft>
+              <a:buSzPct val="75000"/>
+              <a:buFont typeface="StarSymbol"/>
+              <a:buChar char="–"/>
+              <a:defRPr sz="2400">
+                <a:solidFill>
+                  <a:srgbClr val="000000"/>
+                </a:solidFill>
+                <a:latin typeface="Times New Roman" pitchFamily="18" charset="0"/>
+                <a:ea typeface="Microsoft YaHei" pitchFamily="34" charset="-122"/>
+              </a:defRPr>
+            </a:lvl2pPr>
+            <a:lvl3pPr marL="1143000" indent="-228600">
+              <a:spcAft>
+                <a:spcPts val="1413"/>
+              </a:spcAft>
+              <a:buSzPct val="75000"/>
+              <a:buFont typeface="StarSymbol"/>
+              <a:buChar char="●"/>
+              <a:defRPr sz="2400">
+                <a:solidFill>
+                  <a:srgbClr val="000000"/>
+                </a:solidFill>
+                <a:latin typeface="Times New Roman" pitchFamily="18" charset="0"/>
+                <a:ea typeface="Microsoft YaHei" pitchFamily="34" charset="-122"/>
+              </a:defRPr>
+            </a:lvl3pPr>
+            <a:lvl4pPr marL="1600200" indent="-228600">
+              <a:spcAft>
+                <a:spcPts val="1413"/>
+              </a:spcAft>
+              <a:buSzPct val="75000"/>
+              <a:buFont typeface="StarSymbol"/>
+              <a:buChar char="–"/>
+              <a:defRPr sz="2400">
+                <a:solidFill>
+                  <a:srgbClr val="000000"/>
+                </a:solidFill>
+                <a:latin typeface="Times New Roman" pitchFamily="18" charset="0"/>
+                <a:ea typeface="Microsoft YaHei" pitchFamily="34" charset="-122"/>
+              </a:defRPr>
+            </a:lvl4pPr>
+            <a:lvl5pPr marL="2057400" indent="-228600">
+              <a:spcAft>
+                <a:spcPts val="1413"/>
+              </a:spcAft>
+              <a:buSzPct val="75000"/>
+              <a:buFont typeface="StarSymbol"/>
+              <a:buChar char="●"/>
+              <a:defRPr sz="2400">
+                <a:solidFill>
+                  <a:srgbClr val="000000"/>
+                </a:solidFill>
+                <a:latin typeface="Times New Roman" pitchFamily="18" charset="0"/>
+                <a:ea typeface="Microsoft YaHei" pitchFamily="34" charset="-122"/>
+              </a:defRPr>
+            </a:lvl5pPr>
+            <a:lvl6pPr marL="2514600" indent="-228600" eaLnBrk="0" fontAlgn="base" hangingPunct="0">
+              <a:spcBef>
+                <a:spcPct val="0"/>
+              </a:spcBef>
+              <a:spcAft>
+                <a:spcPts val="1413"/>
+              </a:spcAft>
+              <a:buSzPct val="75000"/>
+              <a:buFont typeface="StarSymbol"/>
+              <a:buChar char="●"/>
+              <a:defRPr sz="2400">
+                <a:solidFill>
+                  <a:srgbClr val="000000"/>
+                </a:solidFill>
+                <a:latin typeface="Times New Roman" pitchFamily="18" charset="0"/>
+                <a:ea typeface="Microsoft YaHei" pitchFamily="34" charset="-122"/>
+              </a:defRPr>
+            </a:lvl6pPr>
+            <a:lvl7pPr marL="2971800" indent="-228600" eaLnBrk="0" fontAlgn="base" hangingPunct="0">
+              <a:spcBef>
+                <a:spcPct val="0"/>
+              </a:spcBef>
+              <a:spcAft>
+                <a:spcPts val="1413"/>
+              </a:spcAft>
+              <a:buSzPct val="75000"/>
+              <a:buFont typeface="StarSymbol"/>
+              <a:buChar char="●"/>
+              <a:defRPr sz="2400">
+                <a:solidFill>
+                  <a:srgbClr val="000000"/>
+                </a:solidFill>
+                <a:latin typeface="Times New Roman" pitchFamily="18" charset="0"/>
+                <a:ea typeface="Microsoft YaHei" pitchFamily="34" charset="-122"/>
+              </a:defRPr>
+            </a:lvl7pPr>
+            <a:lvl8pPr marL="3429000" indent="-228600" eaLnBrk="0" fontAlgn="base" hangingPunct="0">
+              <a:spcBef>
+                <a:spcPct val="0"/>
+              </a:spcBef>
+              <a:spcAft>
+                <a:spcPts val="1413"/>
+              </a:spcAft>
+              <a:buSzPct val="75000"/>
+              <a:buFont typeface="StarSymbol"/>
+              <a:buChar char="●"/>
+              <a:defRPr sz="2400">
+                <a:solidFill>
+                  <a:srgbClr val="000000"/>
+                </a:solidFill>
+                <a:latin typeface="Times New Roman" pitchFamily="18" charset="0"/>
+                <a:ea typeface="Microsoft YaHei" pitchFamily="34" charset="-122"/>
+              </a:defRPr>
+            </a:lvl8pPr>
+            <a:lvl9pPr marL="3886200" indent="-228600" eaLnBrk="0" fontAlgn="base" hangingPunct="0">
+              <a:spcBef>
+                <a:spcPct val="0"/>
+              </a:spcBef>
+              <a:spcAft>
+                <a:spcPts val="1413"/>
+              </a:spcAft>
+              <a:buSzPct val="75000"/>
+              <a:buFont typeface="StarSymbol"/>
+              <a:buChar char="●"/>
+              <a:defRPr sz="2400">
+                <a:solidFill>
+                  <a:srgbClr val="000000"/>
+                </a:solidFill>
+                <a:latin typeface="Times New Roman" pitchFamily="18" charset="0"/>
+                <a:ea typeface="Microsoft YaHei" pitchFamily="34" charset="-122"/>
+              </a:defRPr>
+            </a:lvl9pPr>
+          </a:lstStyle>
+          <a:p>
+            <a:pPr algn="ctr" eaLnBrk="1">
+              <a:spcAft>
+                <a:spcPct val="0"/>
+              </a:spcAft>
+              <a:buFontTx/>
+              <a:buNone/>
+            </a:pPr>
+            <a:r>
+              <a:rPr lang="en-US" altLang="en-US" sz="3600">
+                <a:solidFill>
+                  <a:srgbClr val="FFFFFF"/>
+                </a:solidFill>
+                <a:latin typeface="Tahoma" pitchFamily="34" charset="0"/>
+                <a:cs typeface="Tahoma" pitchFamily="34" charset="0"/>
+              </a:rPr>
+              <a:t>Conclusion</a:t>
+            </a:r>
+            <a:endParaRPr lang="en-US" altLang="en-US" sz="2800">
+              <a:solidFill>
+                <a:srgbClr val="FFFFFF"/>
+              </a:solidFill>
+              <a:latin typeface="Tahoma" pitchFamily="34" charset="0"/>
+              <a:cs typeface="Tahoma" pitchFamily="34" charset="0"/>
+            </a:endParaRPr>
+          </a:p>
+        </p:txBody>
+      </p:sp>
+      <p:sp>
+        <p:nvSpPr>
+          <p:cNvPr id="3" name="TextBox 2">
+            <a:extLst>
+              <a:ext uri="{FF2B5EF4-FFF2-40B4-BE49-F238E27FC236}">
+                <a16:creationId xmlns:a16="http://schemas.microsoft.com/office/drawing/2014/main" id="{74D0059A-0651-3F4B-A851-83483B38DF91}"/>
+              </a:ext>
+            </a:extLst>
+          </p:cNvPr>
+          <p:cNvSpPr txBox="1"/>
+          <p:nvPr/>
+        </p:nvSpPr>
+        <p:spPr>
+          <a:xfrm>
+            <a:off x="2286000" y="3110317"/>
+            <a:ext cx="4572000" cy="646331"/>
+          </a:xfrm>
+          <a:prstGeom prst="rect">
+            <a:avLst/>
+          </a:prstGeom>
+          <a:noFill/>
+        </p:spPr>
+        <p:txBody>
+          <a:bodyPr wrap="square">
+            <a:spAutoFit/>
+          </a:bodyPr>
+          <a:lstStyle/>
+          <a:p>
+            <a:r>
+              <a:rPr lang="en-US" dirty="0">
+                <a:hlinkClick r:id="rId3"/>
+              </a:rPr>
+              <a:t>https://github.com/Mikachupichu/central-banking-expert-system/tree/main</a:t>
+            </a:r>
+            <a:endParaRPr lang="en-US" dirty="0"/>
+          </a:p>
+        </p:txBody>
+      </p:sp>
+    </p:spTree>
+  </p:cSld>
+  <p:clrMapOvr>
+    <a:masterClrMapping/>
+  </p:clrMapOvr>
+  <p:transition spd="slow"/>
+  <p:timing>
+    <p:tnLst>
+      <p:par>
+        <p:cTn id="1" dur="indefinite" restart="never" nodeType="tmRoot">
+          <p:childTnLst>
+            <p:seq concurrent="1" nextAc="seek">
+              <p:cTn id="2" dur="indefinite" nodeType="mainSeq">
+                <p:childTnLst>
+                  <p:par>
+                    <p:cTn id="3" fill="hold" nodeType="clickPar">
+                      <p:stCondLst>
+                        <p:cond delay="indefinite"/>
+                      </p:stCondLst>
+                      <p:childTnLst>
+                        <p:par>
+                          <p:cTn id="4" fill="hold" nodeType="withGroup">
+                            <p:stCondLst>
+                              <p:cond delay="0"/>
+                            </p:stCondLst>
+                            <p:childTnLst>
+                              <p:par>
+                                <p:cTn id="5" presetID="4" presetClass="entr" presetSubtype="16" fill="hold" grpId="0" nodeType="clickEffect">
+                                  <p:stCondLst>
+                                    <p:cond delay="0"/>
+                                  </p:stCondLst>
+                                  <p:childTnLst>
+                                    <p:set>
+                                      <p:cBhvr>
+                                        <p:cTn id="6" dur="1" fill="hold">
+                                          <p:stCondLst>
+                                            <p:cond delay="0"/>
+                                          </p:stCondLst>
+                                        </p:cTn>
+                                        <p:tgtEl>
+                                          <p:spTgt spid="5"/>
+                                        </p:tgtEl>
+                                        <p:attrNameLst>
+                                          <p:attrName>style.visibility</p:attrName>
+                                        </p:attrNameLst>
+                                      </p:cBhvr>
+                                      <p:to>
+                                        <p:strVal val="visible"/>
+                                      </p:to>
+                                    </p:set>
+                                    <p:animEffect transition="in" filter="box(in)">
+                                      <p:cBhvr>
+                                        <p:cTn id="7" dur="500"/>
+                                        <p:tgtEl>
+                                          <p:spTgt spid="5"/>
+                                        </p:tgtEl>
+                                      </p:cBhvr>
+                                    </p:animEffect>
+                                  </p:childTnLst>
+                                </p:cTn>
+                              </p:par>
+                            </p:childTnLst>
+                          </p:cTn>
+                        </p:par>
+                      </p:childTnLst>
+                    </p:cTn>
+                  </p:par>
+                </p:childTnLst>
+              </p:cTn>
+              <p:prevCondLst>
+                <p:cond evt="onPrev" delay="0">
+                  <p:tgtEl>
+                    <p:sldTgt/>
+                  </p:tgtEl>
+                </p:cond>
+              </p:prevCondLst>
+              <p:nextCondLst>
+                <p:cond evt="onNext" delay="0">
+                  <p:tgtEl>
+                    <p:sldTgt/>
+                  </p:tgtEl>
+                </p:cond>
+              </p:nextCondLst>
+            </p:seq>
+          </p:childTnLst>
+        </p:cTn>
+      </p:par>
+    </p:tnLst>
+    <p:bldLst>
+      <p:bldP spid="5" grpId="0" autoUpdateAnimBg="0"/>
+    </p:bldLst>
+  </p:timing>
+</p:sld>
+</file>
+
+<file path=ppt/slides/slide2.xml><?xml version="1.0" encoding="utf-8"?>
+<p:sld xmlns:a="http://schemas.openxmlformats.org/drawingml/2006/main" xmlns:r="http://schemas.openxmlformats.org/officeDocument/2006/relationships" xmlns:p="http://schemas.openxmlformats.org/presentationml/2006/main">
+  <p:cSld>
+    <p:spTree>
+      <p:nvGrpSpPr>
+        <p:cNvPr id="1" name=""/>
+        <p:cNvGrpSpPr/>
+        <p:nvPr/>
+      </p:nvGrpSpPr>
+      <p:grpSpPr>
+        <a:xfrm>
+          <a:off x="0" y="0"/>
+          <a:ext cx="0" cy="0"/>
+          <a:chOff x="0" y="0"/>
+          <a:chExt cx="0" cy="0"/>
+        </a:xfrm>
+      </p:grpSpPr>
+      <p:sp>
+        <p:nvSpPr>
+          <p:cNvPr id="4098" name="object 5"/>
+          <p:cNvSpPr>
+            <a:spLocks/>
+          </p:cNvSpPr>
+          <p:nvPr/>
+        </p:nvSpPr>
+        <p:spPr bwMode="auto">
+          <a:xfrm>
+            <a:off x="303213" y="104775"/>
+            <a:ext cx="8662987" cy="812800"/>
+          </a:xfrm>
+          <a:custGeom>
+            <a:avLst/>
+            <a:gdLst>
+              <a:gd name="T0" fmla="*/ 0 w 21600"/>
+              <a:gd name="T1" fmla="*/ 0 h 21600"/>
+              <a:gd name="T2" fmla="*/ 2147483647 w 21600"/>
+              <a:gd name="T3" fmla="*/ 0 h 21600"/>
+              <a:gd name="T4" fmla="*/ 2147483647 w 21600"/>
+              <a:gd name="T5" fmla="*/ 2147483647 h 21600"/>
+              <a:gd name="T6" fmla="*/ 0 w 21600"/>
+              <a:gd name="T7" fmla="*/ 2147483647 h 21600"/>
+              <a:gd name="T8" fmla="*/ 0 w 21600"/>
+              <a:gd name="T9" fmla="*/ 0 h 21600"/>
+              <a:gd name="T10" fmla="*/ 0 60000 65536"/>
+              <a:gd name="T11" fmla="*/ 0 60000 65536"/>
+              <a:gd name="T12" fmla="*/ 0 60000 65536"/>
+              <a:gd name="T13" fmla="*/ 0 60000 65536"/>
+              <a:gd name="T14" fmla="*/ 0 60000 65536"/>
+              <a:gd name="T15" fmla="*/ 0 w 21600"/>
+              <a:gd name="T16" fmla="*/ 0 h 21600"/>
+              <a:gd name="T17" fmla="*/ 21600 w 21600"/>
+              <a:gd name="T18" fmla="*/ 21600 h 21600"/>
+            </a:gdLst>
+            <a:ahLst/>
+            <a:cxnLst>
+              <a:cxn ang="T10">
+                <a:pos x="T0" y="T1"/>
+              </a:cxn>
+              <a:cxn ang="T11">
+                <a:pos x="T2" y="T3"/>
+              </a:cxn>
+              <a:cxn ang="T12">
+                <a:pos x="T4" y="T5"/>
+              </a:cxn>
+              <a:cxn ang="T13">
+                <a:pos x="T6" y="T7"/>
+              </a:cxn>
+              <a:cxn ang="T14">
+                <a:pos x="T8" y="T9"/>
+              </a:cxn>
+            </a:cxnLst>
+            <a:rect l="T15" t="T16" r="T17" b="T18"/>
+            <a:pathLst>
+              <a:path w="21600" h="21600">
+                <a:moveTo>
+                  <a:pt x="0" y="0"/>
+                </a:moveTo>
+                <a:lnTo>
+                  <a:pt x="21600" y="0"/>
+                </a:lnTo>
+                <a:lnTo>
+                  <a:pt x="21600" y="21600"/>
+                </a:lnTo>
+                <a:lnTo>
+                  <a:pt x="0" y="21600"/>
+                </a:lnTo>
+                <a:lnTo>
+                  <a:pt x="0" y="0"/>
+                </a:lnTo>
+                <a:close/>
+              </a:path>
+            </a:pathLst>
+          </a:custGeom>
+          <a:blipFill dpi="0" rotWithShape="1">
+            <a:blip r:embed="rId2"/>
+            <a:srcRect/>
+            <a:stretch>
+              <a:fillRect/>
+            </a:stretch>
+          </a:blipFill>
+          <a:ln>
+            <a:noFill/>
+          </a:ln>
+          <a:extLst>
+            <a:ext uri="{91240B29-F687-4F45-9708-019B960494DF}">
+              <a14:hiddenLine xmlns:a14="http://schemas.microsoft.com/office/drawing/2010/main" w="9525">
+                <a:solidFill>
+                  <a:srgbClr val="000000"/>
+                </a:solidFill>
+                <a:round/>
+                <a:headEnd/>
+                <a:tailEnd/>
+              </a14:hiddenLine>
+            </a:ext>
+          </a:extLst>
+        </p:spPr>
+        <p:txBody>
+          <a:bodyPr lIns="0" tIns="0" rIns="0" bIns="0"/>
+          <a:lstStyle/>
+          <a:p>
+            <a:endParaRPr lang="en-US"/>
+          </a:p>
+        </p:txBody>
+      </p:sp>
+      <p:sp>
+        <p:nvSpPr>
+          <p:cNvPr id="5" name="TextBox 6"/>
+          <p:cNvSpPr txBox="1">
+            <a:spLocks noChangeArrowheads="1"/>
+          </p:cNvSpPr>
+          <p:nvPr/>
+        </p:nvSpPr>
+        <p:spPr bwMode="auto">
+          <a:xfrm>
+            <a:off x="303213" y="1336675"/>
+            <a:ext cx="8662987" cy="1629756"/>
+          </a:xfrm>
+          <a:prstGeom prst="rect">
+            <a:avLst/>
+          </a:prstGeom>
+          <a:noFill/>
+          <a:ln>
+            <a:noFill/>
+          </a:ln>
+          <a:extLst>
+            <a:ext uri="{909E8E84-426E-40DD-AFC4-6F175D3DCCD1}">
+              <a14:hiddenFill xmlns:a14="http://schemas.microsoft.com/office/drawing/2010/main">
+                <a:solidFill>
+                  <a:srgbClr val="FFFFFF"/>
+                </a:solidFill>
+              </a14:hiddenFill>
+            </a:ext>
+            <a:ext uri="{91240B29-F687-4F45-9708-019B960494DF}">
+              <a14:hiddenLine xmlns:a14="http://schemas.microsoft.com/office/drawing/2010/main" w="9525">
+                <a:solidFill>
+                  <a:srgbClr val="000000"/>
+                </a:solidFill>
+                <a:miter lim="800000"/>
+                <a:headEnd/>
+                <a:tailEnd/>
+              </a14:hiddenLine>
+            </a:ext>
+          </a:extLst>
+        </p:spPr>
+        <p:txBody>
+          <a:bodyPr lIns="90004" tIns="44997" rIns="90004" bIns="44997">
+            <a:spAutoFit/>
+          </a:bodyPr>
+          <a:lstStyle>
+            <a:lvl1pPr>
+              <a:spcAft>
+                <a:spcPts val="1413"/>
+              </a:spcAft>
+              <a:buChar char="•"/>
+              <a:defRPr sz="2400">
+                <a:solidFill>
+                  <a:srgbClr val="000000"/>
+                </a:solidFill>
+                <a:latin typeface="Times New Roman" pitchFamily="18" charset="0"/>
+                <a:ea typeface="Microsoft YaHei" pitchFamily="34" charset="-122"/>
+              </a:defRPr>
+            </a:lvl1pPr>
+            <a:lvl2pPr marL="742950" indent="-285750">
+              <a:spcAft>
+                <a:spcPts val="1413"/>
+              </a:spcAft>
+              <a:buSzPct val="75000"/>
+              <a:buFont typeface="StarSymbol"/>
+              <a:buChar char="–"/>
+              <a:defRPr sz="2400">
+                <a:solidFill>
+                  <a:srgbClr val="000000"/>
+                </a:solidFill>
+                <a:latin typeface="Times New Roman" pitchFamily="18" charset="0"/>
+                <a:ea typeface="Microsoft YaHei" pitchFamily="34" charset="-122"/>
+              </a:defRPr>
+            </a:lvl2pPr>
+            <a:lvl3pPr marL="1143000" indent="-228600">
+              <a:spcAft>
+                <a:spcPts val="1413"/>
+              </a:spcAft>
+              <a:buSzPct val="75000"/>
+              <a:buFont typeface="StarSymbol"/>
+              <a:buChar char="●"/>
+              <a:defRPr sz="2400">
+                <a:solidFill>
+                  <a:srgbClr val="000000"/>
+                </a:solidFill>
+                <a:latin typeface="Times New Roman" pitchFamily="18" charset="0"/>
+                <a:ea typeface="Microsoft YaHei" pitchFamily="34" charset="-122"/>
+              </a:defRPr>
+            </a:lvl3pPr>
+            <a:lvl4pPr marL="1600200" indent="-228600">
+              <a:spcAft>
+                <a:spcPts val="1413"/>
+              </a:spcAft>
+              <a:buSzPct val="75000"/>
+              <a:buFont typeface="StarSymbol"/>
+              <a:buChar char="–"/>
+              <a:defRPr sz="2400">
+                <a:solidFill>
+                  <a:srgbClr val="000000"/>
+                </a:solidFill>
+                <a:latin typeface="Times New Roman" pitchFamily="18" charset="0"/>
+                <a:ea typeface="Microsoft YaHei" pitchFamily="34" charset="-122"/>
+              </a:defRPr>
+            </a:lvl4pPr>
+            <a:lvl5pPr marL="2057400" indent="-228600">
+              <a:spcAft>
+                <a:spcPts val="1413"/>
+              </a:spcAft>
+              <a:buSzPct val="75000"/>
+              <a:buFont typeface="StarSymbol"/>
+              <a:buChar char="●"/>
+              <a:defRPr sz="2400">
+                <a:solidFill>
+                  <a:srgbClr val="000000"/>
+                </a:solidFill>
+                <a:latin typeface="Times New Roman" pitchFamily="18" charset="0"/>
+                <a:ea typeface="Microsoft YaHei" pitchFamily="34" charset="-122"/>
+              </a:defRPr>
+            </a:lvl5pPr>
+            <a:lvl6pPr marL="2514600" indent="-228600" eaLnBrk="0" fontAlgn="base" hangingPunct="0">
+              <a:spcBef>
+                <a:spcPct val="0"/>
+              </a:spcBef>
+              <a:spcAft>
+                <a:spcPts val="1413"/>
+              </a:spcAft>
+              <a:buSzPct val="75000"/>
+              <a:buFont typeface="StarSymbol"/>
+              <a:buChar char="●"/>
+              <a:defRPr sz="2400">
+                <a:solidFill>
+                  <a:srgbClr val="000000"/>
+                </a:solidFill>
+                <a:latin typeface="Times New Roman" pitchFamily="18" charset="0"/>
+                <a:ea typeface="Microsoft YaHei" pitchFamily="34" charset="-122"/>
+              </a:defRPr>
+            </a:lvl6pPr>
+            <a:lvl7pPr marL="2971800" indent="-228600" eaLnBrk="0" fontAlgn="base" hangingPunct="0">
+              <a:spcBef>
+                <a:spcPct val="0"/>
+              </a:spcBef>
+              <a:spcAft>
+                <a:spcPts val="1413"/>
+              </a:spcAft>
+              <a:buSzPct val="75000"/>
+              <a:buFont typeface="StarSymbol"/>
+              <a:buChar char="●"/>
+              <a:defRPr sz="2400">
+                <a:solidFill>
+                  <a:srgbClr val="000000"/>
+                </a:solidFill>
+                <a:latin typeface="Times New Roman" pitchFamily="18" charset="0"/>
+                <a:ea typeface="Microsoft YaHei" pitchFamily="34" charset="-122"/>
+              </a:defRPr>
+            </a:lvl7pPr>
+            <a:lvl8pPr marL="3429000" indent="-228600" eaLnBrk="0" fontAlgn="base" hangingPunct="0">
+              <a:spcBef>
+                <a:spcPct val="0"/>
+              </a:spcBef>
+              <a:spcAft>
+                <a:spcPts val="1413"/>
+              </a:spcAft>
+              <a:buSzPct val="75000"/>
+              <a:buFont typeface="StarSymbol"/>
+              <a:buChar char="●"/>
+              <a:defRPr sz="2400">
+                <a:solidFill>
+                  <a:srgbClr val="000000"/>
+                </a:solidFill>
+                <a:latin typeface="Times New Roman" pitchFamily="18" charset="0"/>
+                <a:ea typeface="Microsoft YaHei" pitchFamily="34" charset="-122"/>
+              </a:defRPr>
+            </a:lvl8pPr>
+            <a:lvl9pPr marL="3886200" indent="-228600" eaLnBrk="0" fontAlgn="base" hangingPunct="0">
+              <a:spcBef>
+                <a:spcPct val="0"/>
+              </a:spcBef>
+              <a:spcAft>
+                <a:spcPts val="1413"/>
+              </a:spcAft>
+              <a:buSzPct val="75000"/>
+              <a:buFont typeface="StarSymbol"/>
+              <a:buChar char="●"/>
+              <a:defRPr sz="2400">
+                <a:solidFill>
+                  <a:srgbClr val="000000"/>
+                </a:solidFill>
+                <a:latin typeface="Times New Roman" pitchFamily="18" charset="0"/>
+                <a:ea typeface="Microsoft YaHei" pitchFamily="34" charset="-122"/>
+              </a:defRPr>
+            </a:lvl9pPr>
+          </a:lstStyle>
+          <a:p>
+            <a:pPr marL="457200" indent="-457200" algn="just" eaLnBrk="1">
+              <a:spcAft>
+                <a:spcPct val="0"/>
+              </a:spcAft>
+              <a:buFont typeface="+mj-lt"/>
+              <a:buAutoNum type="arabicPeriod"/>
+            </a:pPr>
+            <a:r>
+              <a:rPr lang="en-US" altLang="en-US" sz="2000" dirty="0">
+                <a:solidFill>
+                  <a:srgbClr val="1C1C1C"/>
+                </a:solidFill>
+                <a:latin typeface="Tahoma" pitchFamily="34" charset="0"/>
+                <a:cs typeface="Tahoma" pitchFamily="34" charset="0"/>
+              </a:rPr>
+              <a:t>Lessons Learned from D1 (TODO 1)</a:t>
+            </a:r>
+          </a:p>
+          <a:p>
+            <a:pPr marL="457200" indent="-457200" algn="just" eaLnBrk="1">
+              <a:spcAft>
+                <a:spcPct val="0"/>
+              </a:spcAft>
+              <a:buFont typeface="+mj-lt"/>
+              <a:buAutoNum type="arabicPeriod"/>
+            </a:pPr>
+            <a:r>
+              <a:rPr lang="en-US" altLang="en-US" sz="2000" dirty="0">
+                <a:solidFill>
+                  <a:srgbClr val="1C1C1C"/>
+                </a:solidFill>
+                <a:latin typeface="Tahoma" pitchFamily="34" charset="0"/>
+                <a:cs typeface="Tahoma" pitchFamily="34" charset="0"/>
+              </a:rPr>
+              <a:t>Probabilistic Uncertainty (TODO 2)</a:t>
+            </a:r>
+          </a:p>
+          <a:p>
+            <a:pPr marL="457200" indent="-457200" algn="just" eaLnBrk="1">
+              <a:spcAft>
+                <a:spcPct val="0"/>
+              </a:spcAft>
+              <a:buFont typeface="+mj-lt"/>
+              <a:buAutoNum type="arabicPeriod"/>
+            </a:pPr>
+            <a:r>
+              <a:rPr lang="en-US" altLang="en-US" sz="2000" dirty="0">
+                <a:solidFill>
+                  <a:srgbClr val="1C1C1C"/>
+                </a:solidFill>
+                <a:latin typeface="Tahoma" pitchFamily="34" charset="0"/>
+                <a:cs typeface="Tahoma" pitchFamily="34" charset="0"/>
+              </a:rPr>
+              <a:t>Possibilistic Uncertainty (TODO 3)</a:t>
+            </a:r>
+          </a:p>
+          <a:p>
+            <a:pPr marL="457200" indent="-457200" algn="just" eaLnBrk="1">
+              <a:spcAft>
+                <a:spcPct val="0"/>
+              </a:spcAft>
+              <a:buFont typeface="+mj-lt"/>
+              <a:buAutoNum type="arabicPeriod"/>
+            </a:pPr>
+            <a:r>
+              <a:rPr lang="en-US" altLang="en-US" sz="2000" dirty="0">
+                <a:solidFill>
+                  <a:srgbClr val="1C1C1C"/>
+                </a:solidFill>
+                <a:latin typeface="Tahoma" pitchFamily="34" charset="0"/>
+                <a:cs typeface="Tahoma" pitchFamily="34" charset="0"/>
+              </a:rPr>
+              <a:t>Quality Attributes (TODO 4)</a:t>
+            </a:r>
+          </a:p>
+          <a:p>
+            <a:pPr marL="457200" indent="-457200" algn="just" eaLnBrk="1">
+              <a:spcAft>
+                <a:spcPct val="0"/>
+              </a:spcAft>
+              <a:buFont typeface="+mj-lt"/>
+              <a:buAutoNum type="arabicPeriod"/>
+            </a:pPr>
+            <a:r>
+              <a:rPr lang="en-US" altLang="en-US" sz="2000" dirty="0">
+                <a:solidFill>
+                  <a:srgbClr val="1C1C1C"/>
+                </a:solidFill>
+                <a:latin typeface="Tahoma" pitchFamily="34" charset="0"/>
+                <a:cs typeface="Tahoma" pitchFamily="34" charset="0"/>
+              </a:rPr>
+              <a:t>Conclusion</a:t>
             </a:r>
           </a:p>
         </p:txBody>
@@ -9755,7 +10520,7 @@
         <p:spPr bwMode="auto">
           <a:xfrm>
             <a:off x="303213" y="1336675"/>
-            <a:ext cx="8662987" cy="3476415"/>
+            <a:ext cx="8662987" cy="1629756"/>
           </a:xfrm>
           <a:prstGeom prst="rect">
             <a:avLst/>
@@ -9951,27 +10716,7 @@
                 <a:latin typeface="Tahoma" pitchFamily="34" charset="0"/>
                 <a:cs typeface="Tahoma" pitchFamily="34" charset="0"/>
               </a:rPr>
-              <a:t>Most of the marks I lost were related to a lack of documentation in the PowerPoint. My work was instead documented as code comments. Professor </a:t>
-            </a:r>
-            <a:r>
-              <a:rPr lang="en-US" altLang="en-US" sz="2000" dirty="0" err="1">
-                <a:solidFill>
-                  <a:srgbClr val="1C1C1C"/>
-                </a:solidFill>
-                <a:latin typeface="Tahoma" pitchFamily="34" charset="0"/>
-                <a:cs typeface="Tahoma" pitchFamily="34" charset="0"/>
-              </a:rPr>
-              <a:t>Kamthan</a:t>
-            </a:r>
-            <a:r>
-              <a:rPr lang="en-US" altLang="en-US" sz="2000" dirty="0">
-                <a:solidFill>
-                  <a:srgbClr val="1C1C1C"/>
-                </a:solidFill>
-                <a:latin typeface="Tahoma" pitchFamily="34" charset="0"/>
-                <a:cs typeface="Tahoma" pitchFamily="34" charset="0"/>
-              </a:rPr>
-              <a:t> has agreed to accept in-code documentation and grant those marks. Other marks were initially lost for a lack of modularity, but I pointed out to my TA that modularity had not been taught before the D1 submission date. I performed very poorly in testing due to not having documented any of my tests. A major part of my expert system that must change is the lack of interactivity, as brought up to me in the D1 demo feedback. I will thus allow users to interact with my expert system directly through the CLI rather than by expecting them to add or remove facts from the database.</a:t>
+              <a:t>Although I performed very well and received a good grade, a major part of my expert system that must change is the lack of interactivity, as brought up to me in the D1 demo feedback. I will thus allow users to interact with my expert system directly through the CLI rather than by expecting them to add, modify or remove facts from the database.</a:t>
             </a:r>
           </a:p>
         </p:txBody>
@@ -12138,6 +12883,74 @@
           </a:p>
         </p:txBody>
       </p:sp>
+      <p:pic>
+        <p:nvPicPr>
+          <p:cNvPr id="7" name="Picture 6">
+            <a:extLst>
+              <a:ext uri="{FF2B5EF4-FFF2-40B4-BE49-F238E27FC236}">
+                <a16:creationId xmlns:a16="http://schemas.microsoft.com/office/drawing/2014/main" id="{01D23C6C-35F9-DD1C-62AB-267EAAF4241F}"/>
+              </a:ext>
+            </a:extLst>
+          </p:cNvPr>
+          <p:cNvPicPr>
+            <a:picLocks noChangeAspect="1"/>
+          </p:cNvPicPr>
+          <p:nvPr/>
+        </p:nvPicPr>
+        <p:blipFill>
+          <a:blip r:embed="rId3"/>
+          <a:stretch>
+            <a:fillRect/>
+          </a:stretch>
+        </p:blipFill>
+        <p:spPr>
+          <a:xfrm>
+            <a:off x="588963" y="4467245"/>
+            <a:ext cx="3527612" cy="2479873"/>
+          </a:xfrm>
+          <a:prstGeom prst="rect">
+            <a:avLst/>
+          </a:prstGeom>
+        </p:spPr>
+      </p:pic>
+      <p:sp>
+        <p:nvSpPr>
+          <p:cNvPr id="9" name="TextBox 8">
+            <a:extLst>
+              <a:ext uri="{FF2B5EF4-FFF2-40B4-BE49-F238E27FC236}">
+                <a16:creationId xmlns:a16="http://schemas.microsoft.com/office/drawing/2014/main" id="{BFF84538-DA5E-DDD9-DC8D-56752AD5B7A3}"/>
+              </a:ext>
+            </a:extLst>
+          </p:cNvPr>
+          <p:cNvSpPr txBox="1"/>
+          <p:nvPr/>
+        </p:nvSpPr>
+        <p:spPr>
+          <a:xfrm>
+            <a:off x="4394200" y="4737685"/>
+            <a:ext cx="4572000" cy="646331"/>
+          </a:xfrm>
+          <a:prstGeom prst="rect">
+            <a:avLst/>
+          </a:prstGeom>
+          <a:noFill/>
+        </p:spPr>
+        <p:txBody>
+          <a:bodyPr wrap="square">
+            <a:spAutoFit/>
+          </a:bodyPr>
+          <a:lstStyle/>
+          <a:p>
+            <a:r>
+              <a:rPr lang="en-US" dirty="0">
+                <a:hlinkClick r:id="rId4"/>
+              </a:rPr>
+              <a:t>https://github.com/Mikachupichu/central-banking-expert-system/tree/TODO3</a:t>
+            </a:r>
+            <a:endParaRPr lang="en-US" dirty="0"/>
+          </a:p>
+        </p:txBody>
+      </p:sp>
     </p:spTree>
     <p:extLst>
       <p:ext uri="{BB962C8B-B14F-4D97-AF65-F5344CB8AC3E}">
@@ -12513,6 +13326,161 @@
           </a:p>
         </p:txBody>
       </p:sp>
+      <p:sp>
+        <p:nvSpPr>
+          <p:cNvPr id="3" name="TextBox 2">
+            <a:extLst>
+              <a:ext uri="{FF2B5EF4-FFF2-40B4-BE49-F238E27FC236}">
+                <a16:creationId xmlns:a16="http://schemas.microsoft.com/office/drawing/2014/main" id="{B1486129-C845-2327-6107-5FB23DD2695A}"/>
+              </a:ext>
+            </a:extLst>
+          </p:cNvPr>
+          <p:cNvSpPr txBox="1"/>
+          <p:nvPr/>
+        </p:nvSpPr>
+        <p:spPr>
+          <a:xfrm>
+            <a:off x="303213" y="917575"/>
+            <a:ext cx="8662987" cy="5262979"/>
+          </a:xfrm>
+          <a:prstGeom prst="rect">
+            <a:avLst/>
+          </a:prstGeom>
+          <a:noFill/>
+        </p:spPr>
+        <p:txBody>
+          <a:bodyPr wrap="square">
+            <a:spAutoFit/>
+          </a:bodyPr>
+          <a:lstStyle/>
+          <a:p>
+            <a:pPr marL="342900" indent="-342900" algn="just" eaLnBrk="1">
+              <a:buAutoNum type="arabicPeriod"/>
+            </a:pPr>
+            <a:r>
+              <a:rPr lang="en-US" altLang="en-US" sz="1600" dirty="0">
+                <a:solidFill>
+                  <a:srgbClr val="1C1C1C"/>
+                </a:solidFill>
+                <a:latin typeface="Tahoma" pitchFamily="34" charset="0"/>
+                <a:cs typeface="Tahoma" pitchFamily="34" charset="0"/>
+              </a:rPr>
+              <a:t>Correctness</a:t>
+            </a:r>
+          </a:p>
+          <a:p>
+            <a:pPr marL="800100" lvl="1" indent="-342900" algn="just" eaLnBrk="1">
+              <a:buFont typeface="Courier New" panose="02070309020205020404" pitchFamily="49" charset="0"/>
+              <a:buChar char="o"/>
+            </a:pPr>
+            <a:r>
+              <a:rPr lang="en-US" altLang="en-US" sz="1600" dirty="0">
+                <a:solidFill>
+                  <a:srgbClr val="1C1C1C"/>
+                </a:solidFill>
+                <a:latin typeface="Tahoma" pitchFamily="34" charset="0"/>
+                <a:cs typeface="Tahoma" pitchFamily="34" charset="0"/>
+              </a:rPr>
+              <a:t>Rules must accurately represent central banking knowledge. For example, an economics student relying and trusting my expert system must not be taught incorrect information that may negatively impact his grades.</a:t>
+            </a:r>
+          </a:p>
+          <a:p>
+            <a:pPr marL="800100" lvl="1" indent="-342900" algn="just" eaLnBrk="1">
+              <a:buFont typeface="Courier New" panose="02070309020205020404" pitchFamily="49" charset="0"/>
+              <a:buChar char="o"/>
+            </a:pPr>
+            <a:r>
+              <a:rPr lang="en-US" altLang="en-US" sz="1600" dirty="0">
+                <a:solidFill>
+                  <a:srgbClr val="1C1C1C"/>
+                </a:solidFill>
+                <a:latin typeface="Tahoma" pitchFamily="34" charset="0"/>
+                <a:cs typeface="Tahoma" pitchFamily="34" charset="0"/>
+              </a:rPr>
+              <a:t>All theory behind all rules is cited and references authoritative and academic sources throughout my code, ensuring correctness. Comments above each rule and at the very bottom of the knowledgebase are used for this purpose. Limitations of the expert system are acknowledged in the D1 documentation slides.</a:t>
+            </a:r>
+          </a:p>
+          <a:p>
+            <a:pPr marL="800100" lvl="1" indent="-342900" algn="just" eaLnBrk="1">
+              <a:buFont typeface="Courier New" panose="02070309020205020404" pitchFamily="49" charset="0"/>
+              <a:buChar char="o"/>
+            </a:pPr>
+            <a:r>
+              <a:rPr lang="en-US" altLang="en-US" sz="1600" dirty="0">
+                <a:solidFill>
+                  <a:srgbClr val="1C1C1C"/>
+                </a:solidFill>
+                <a:latin typeface="Tahoma" pitchFamily="34" charset="0"/>
+                <a:cs typeface="Tahoma" pitchFamily="34" charset="0"/>
+              </a:rPr>
+              <a:t>Consequently, knowledge is accurately represented using rules. The impact of these guidelines are highly positive.</a:t>
+            </a:r>
+          </a:p>
+          <a:p>
+            <a:pPr marL="342900" indent="-342900" algn="just" eaLnBrk="1">
+              <a:buAutoNum type="arabicPeriod"/>
+            </a:pPr>
+            <a:r>
+              <a:rPr lang="en-US" altLang="en-US" sz="1600" dirty="0">
+                <a:solidFill>
+                  <a:srgbClr val="1C1C1C"/>
+                </a:solidFill>
+                <a:latin typeface="Tahoma" pitchFamily="34" charset="0"/>
+                <a:cs typeface="Tahoma" pitchFamily="34" charset="0"/>
+              </a:rPr>
+              <a:t>Consistency</a:t>
+            </a:r>
+          </a:p>
+          <a:p>
+            <a:pPr marL="800100" lvl="1" indent="-342900" algn="just" eaLnBrk="1">
+              <a:buFont typeface="Courier New" panose="02070309020205020404" pitchFamily="49" charset="0"/>
+              <a:buChar char="o"/>
+            </a:pPr>
+            <a:r>
+              <a:rPr lang="en-US" altLang="en-US" sz="1600" dirty="0">
+                <a:solidFill>
+                  <a:srgbClr val="1C1C1C"/>
+                </a:solidFill>
+                <a:latin typeface="Tahoma" pitchFamily="34" charset="0"/>
+                <a:cs typeface="Tahoma" pitchFamily="34" charset="0"/>
+              </a:rPr>
+              <a:t>Rules must not contradict each other, as that would render the expert system less trustworthy.</a:t>
+            </a:r>
+          </a:p>
+          <a:p>
+            <a:pPr marL="800100" lvl="1" indent="-342900" algn="just" eaLnBrk="1">
+              <a:buFont typeface="Courier New" panose="02070309020205020404" pitchFamily="49" charset="0"/>
+              <a:buChar char="o"/>
+            </a:pPr>
+            <a:r>
+              <a:rPr lang="en-US" altLang="en-US" sz="1600" dirty="0">
+                <a:solidFill>
+                  <a:srgbClr val="1C1C1C"/>
+                </a:solidFill>
+                <a:latin typeface="Tahoma" pitchFamily="34" charset="0"/>
+                <a:cs typeface="Tahoma" pitchFamily="34" charset="0"/>
+              </a:rPr>
+              <a:t>There are no repeating terms (concepts) between different contexts. Moreover, any potential contradictions are handled by the use of fuzziness (when fact assertions conflict), salience (in setup rules to ensure all rules are fired and facts are asserted before reaching the conclusion rule, thus preventing it from firing multiple times due to changing information), and stop facts (when the conclusion fires, to avoid repeats).</a:t>
+            </a:r>
+          </a:p>
+          <a:p>
+            <a:pPr marL="800100" lvl="1" indent="-342900" algn="just" eaLnBrk="1">
+              <a:buFont typeface="Courier New" panose="02070309020205020404" pitchFamily="49" charset="0"/>
+              <a:buChar char="o"/>
+            </a:pPr>
+            <a:r>
+              <a:rPr lang="en-US" altLang="en-US" sz="1600" dirty="0">
+                <a:solidFill>
+                  <a:srgbClr val="1C1C1C"/>
+                </a:solidFill>
+                <a:latin typeface="Tahoma" pitchFamily="34" charset="0"/>
+                <a:cs typeface="Tahoma" pitchFamily="34" charset="0"/>
+              </a:rPr>
+              <a:t>The effect of such consistency is positive, as users can safely rely on the expert system’s answers.</a:t>
+            </a:r>
+          </a:p>
+        </p:txBody>
+      </p:sp>
     </p:spTree>
     <p:extLst>
       <p:ext uri="{BB962C8B-B14F-4D97-AF65-F5344CB8AC3E}">
@@ -12532,7 +13500,13 @@
   <p:cSld>
     <p:spTree>
       <p:nvGrpSpPr>
-        <p:cNvPr id="1" name=""/>
+        <p:cNvPr id="1" name="">
+          <a:extLst>
+            <a:ext uri="{FF2B5EF4-FFF2-40B4-BE49-F238E27FC236}">
+              <a16:creationId xmlns:a16="http://schemas.microsoft.com/office/drawing/2014/main" id="{B94AB586-D102-2193-D1D4-331851D40A9C}"/>
+            </a:ext>
+          </a:extLst>
+        </p:cNvPr>
         <p:cNvGrpSpPr/>
         <p:nvPr/>
       </p:nvGrpSpPr>
@@ -12546,7 +13520,13 @@
       </p:grpSpPr>
       <p:sp>
         <p:nvSpPr>
-          <p:cNvPr id="5122" name="object 5"/>
+          <p:cNvPr id="4098" name="object 5">
+            <a:extLst>
+              <a:ext uri="{FF2B5EF4-FFF2-40B4-BE49-F238E27FC236}">
+                <a16:creationId xmlns:a16="http://schemas.microsoft.com/office/drawing/2014/main" id="{2D80E69F-08A1-16F0-4A18-95518FA7418F}"/>
+              </a:ext>
+            </a:extLst>
+          </p:cNvPr>
           <p:cNvSpPr>
             <a:spLocks/>
           </p:cNvSpPr>
@@ -12653,7 +13633,13 @@
       </p:sp>
       <p:sp>
         <p:nvSpPr>
-          <p:cNvPr id="5" name="TextBox 6"/>
+          <p:cNvPr id="4100" name="object 7">
+            <a:extLst>
+              <a:ext uri="{FF2B5EF4-FFF2-40B4-BE49-F238E27FC236}">
+                <a16:creationId xmlns:a16="http://schemas.microsoft.com/office/drawing/2014/main" id="{EE475F07-7181-E422-EB2E-BF14D374D4D3}"/>
+              </a:ext>
+            </a:extLst>
+          </p:cNvPr>
           <p:cNvSpPr txBox="1">
             <a:spLocks noChangeArrowheads="1"/>
           </p:cNvSpPr>
@@ -12661,8 +13647,8 @@
         </p:nvSpPr>
         <p:spPr bwMode="auto">
           <a:xfrm>
-            <a:off x="303213" y="1336675"/>
-            <a:ext cx="8662987" cy="398463"/>
+            <a:off x="588963" y="238125"/>
+            <a:ext cx="8091487" cy="553998"/>
           </a:xfrm>
           <a:prstGeom prst="rect">
             <a:avLst/>
@@ -12692,11 +13678,11 @@
           </a:extLst>
         </p:spPr>
         <p:txBody>
-          <a:bodyPr lIns="90004" tIns="44997" rIns="90004" bIns="44997">
+          <a:bodyPr lIns="0" tIns="0" rIns="0" bIns="0" anchorCtr="1">
             <a:spAutoFit/>
           </a:bodyPr>
           <a:lstStyle>
-            <a:lvl1pPr>
+            <a:lvl1pPr marL="11113">
               <a:spcAft>
                 <a:spcPts val="1413"/>
               </a:spcAft>
@@ -12709,7 +13695,7 @@
                 <a:ea typeface="Microsoft YaHei" pitchFamily="34" charset="-122"/>
               </a:defRPr>
             </a:lvl1pPr>
-            <a:lvl2pPr marL="742950" indent="-285750">
+            <a:lvl2pPr marL="685800" indent="-228600">
               <a:spcAft>
                 <a:spcPts val="1413"/>
               </a:spcAft>
@@ -12843,218 +13829,6 @@
             </a:lvl9pPr>
           </a:lstStyle>
           <a:p>
-            <a:pPr algn="just" eaLnBrk="1">
-              <a:spcAft>
-                <a:spcPct val="0"/>
-              </a:spcAft>
-              <a:buFontTx/>
-              <a:buNone/>
-            </a:pPr>
-            <a:r>
-              <a:rPr lang="en-US" altLang="en-US" sz="2000">
-                <a:solidFill>
-                  <a:srgbClr val="1C1C1C"/>
-                </a:solidFill>
-                <a:latin typeface="Tahoma" pitchFamily="34" charset="0"/>
-                <a:cs typeface="Tahoma" pitchFamily="34" charset="0"/>
-              </a:rPr>
-              <a:t>Add Text</a:t>
-            </a:r>
-          </a:p>
-        </p:txBody>
-      </p:sp>
-      <p:sp>
-        <p:nvSpPr>
-          <p:cNvPr id="5124" name="object 7"/>
-          <p:cNvSpPr txBox="1">
-            <a:spLocks noChangeArrowheads="1"/>
-          </p:cNvSpPr>
-          <p:nvPr/>
-        </p:nvSpPr>
-        <p:spPr bwMode="auto">
-          <a:xfrm>
-            <a:off x="588963" y="238125"/>
-            <a:ext cx="8091487" cy="554038"/>
-          </a:xfrm>
-          <a:prstGeom prst="rect">
-            <a:avLst/>
-          </a:prstGeom>
-          <a:noFill/>
-          <a:ln>
-            <a:noFill/>
-          </a:ln>
-          <a:extLst>
-            <a:ext uri="{909E8E84-426E-40DD-AFC4-6F175D3DCCD1}">
-              <a14:hiddenFill xmlns:a14="http://schemas.microsoft.com/office/drawing/2010/main">
-                <a:solidFill>
-                  <a:srgbClr val="FFFFFF"/>
-                </a:solidFill>
-              </a14:hiddenFill>
-            </a:ext>
-            <a:ext uri="{91240B29-F687-4F45-9708-019B960494DF}">
-              <a14:hiddenLine xmlns:a14="http://schemas.microsoft.com/office/drawing/2010/main" w="9525">
-                <a:solidFill>
-                  <a:srgbClr val="000000"/>
-                </a:solidFill>
-                <a:miter lim="800000"/>
-                <a:headEnd/>
-                <a:tailEnd/>
-              </a14:hiddenLine>
-            </a:ext>
-          </a:extLst>
-        </p:spPr>
-        <p:txBody>
-          <a:bodyPr lIns="0" tIns="0" rIns="0" bIns="0" anchorCtr="1">
-            <a:spAutoFit/>
-          </a:bodyPr>
-          <a:lstStyle>
-            <a:lvl1pPr marL="11113">
-              <a:spcAft>
-                <a:spcPts val="1413"/>
-              </a:spcAft>
-              <a:buChar char="•"/>
-              <a:defRPr sz="2400">
-                <a:solidFill>
-                  <a:srgbClr val="000000"/>
-                </a:solidFill>
-                <a:latin typeface="Times New Roman" pitchFamily="18" charset="0"/>
-                <a:ea typeface="Microsoft YaHei" pitchFamily="34" charset="-122"/>
-              </a:defRPr>
-            </a:lvl1pPr>
-            <a:lvl2pPr marL="685800" indent="-228600">
-              <a:spcAft>
-                <a:spcPts val="1413"/>
-              </a:spcAft>
-              <a:buSzPct val="75000"/>
-              <a:buFont typeface="StarSymbol"/>
-              <a:buChar char="–"/>
-              <a:defRPr sz="2400">
-                <a:solidFill>
-                  <a:srgbClr val="000000"/>
-                </a:solidFill>
-                <a:latin typeface="Times New Roman" pitchFamily="18" charset="0"/>
-                <a:ea typeface="Microsoft YaHei" pitchFamily="34" charset="-122"/>
-              </a:defRPr>
-            </a:lvl2pPr>
-            <a:lvl3pPr marL="1143000" indent="-228600">
-              <a:spcAft>
-                <a:spcPts val="1413"/>
-              </a:spcAft>
-              <a:buSzPct val="75000"/>
-              <a:buFont typeface="StarSymbol"/>
-              <a:buChar char="●"/>
-              <a:defRPr sz="2400">
-                <a:solidFill>
-                  <a:srgbClr val="000000"/>
-                </a:solidFill>
-                <a:latin typeface="Times New Roman" pitchFamily="18" charset="0"/>
-                <a:ea typeface="Microsoft YaHei" pitchFamily="34" charset="-122"/>
-              </a:defRPr>
-            </a:lvl3pPr>
-            <a:lvl4pPr marL="1600200" indent="-228600">
-              <a:spcAft>
-                <a:spcPts val="1413"/>
-              </a:spcAft>
-              <a:buSzPct val="75000"/>
-              <a:buFont typeface="StarSymbol"/>
-              <a:buChar char="–"/>
-              <a:defRPr sz="2400">
-                <a:solidFill>
-                  <a:srgbClr val="000000"/>
-                </a:solidFill>
-                <a:latin typeface="Times New Roman" pitchFamily="18" charset="0"/>
-                <a:ea typeface="Microsoft YaHei" pitchFamily="34" charset="-122"/>
-              </a:defRPr>
-            </a:lvl4pPr>
-            <a:lvl5pPr marL="2057400" indent="-228600">
-              <a:spcAft>
-                <a:spcPts val="1413"/>
-              </a:spcAft>
-              <a:buSzPct val="75000"/>
-              <a:buFont typeface="StarSymbol"/>
-              <a:buChar char="●"/>
-              <a:defRPr sz="2400">
-                <a:solidFill>
-                  <a:srgbClr val="000000"/>
-                </a:solidFill>
-                <a:latin typeface="Times New Roman" pitchFamily="18" charset="0"/>
-                <a:ea typeface="Microsoft YaHei" pitchFamily="34" charset="-122"/>
-              </a:defRPr>
-            </a:lvl5pPr>
-            <a:lvl6pPr marL="2514600" indent="-228600" eaLnBrk="0" fontAlgn="base" hangingPunct="0">
-              <a:spcBef>
-                <a:spcPct val="0"/>
-              </a:spcBef>
-              <a:spcAft>
-                <a:spcPts val="1413"/>
-              </a:spcAft>
-              <a:buSzPct val="75000"/>
-              <a:buFont typeface="StarSymbol"/>
-              <a:buChar char="●"/>
-              <a:defRPr sz="2400">
-                <a:solidFill>
-                  <a:srgbClr val="000000"/>
-                </a:solidFill>
-                <a:latin typeface="Times New Roman" pitchFamily="18" charset="0"/>
-                <a:ea typeface="Microsoft YaHei" pitchFamily="34" charset="-122"/>
-              </a:defRPr>
-            </a:lvl6pPr>
-            <a:lvl7pPr marL="2971800" indent="-228600" eaLnBrk="0" fontAlgn="base" hangingPunct="0">
-              <a:spcBef>
-                <a:spcPct val="0"/>
-              </a:spcBef>
-              <a:spcAft>
-                <a:spcPts val="1413"/>
-              </a:spcAft>
-              <a:buSzPct val="75000"/>
-              <a:buFont typeface="StarSymbol"/>
-              <a:buChar char="●"/>
-              <a:defRPr sz="2400">
-                <a:solidFill>
-                  <a:srgbClr val="000000"/>
-                </a:solidFill>
-                <a:latin typeface="Times New Roman" pitchFamily="18" charset="0"/>
-                <a:ea typeface="Microsoft YaHei" pitchFamily="34" charset="-122"/>
-              </a:defRPr>
-            </a:lvl7pPr>
-            <a:lvl8pPr marL="3429000" indent="-228600" eaLnBrk="0" fontAlgn="base" hangingPunct="0">
-              <a:spcBef>
-                <a:spcPct val="0"/>
-              </a:spcBef>
-              <a:spcAft>
-                <a:spcPts val="1413"/>
-              </a:spcAft>
-              <a:buSzPct val="75000"/>
-              <a:buFont typeface="StarSymbol"/>
-              <a:buChar char="●"/>
-              <a:defRPr sz="2400">
-                <a:solidFill>
-                  <a:srgbClr val="000000"/>
-                </a:solidFill>
-                <a:latin typeface="Times New Roman" pitchFamily="18" charset="0"/>
-                <a:ea typeface="Microsoft YaHei" pitchFamily="34" charset="-122"/>
-              </a:defRPr>
-            </a:lvl8pPr>
-            <a:lvl9pPr marL="3886200" indent="-228600" eaLnBrk="0" fontAlgn="base" hangingPunct="0">
-              <a:spcBef>
-                <a:spcPct val="0"/>
-              </a:spcBef>
-              <a:spcAft>
-                <a:spcPts val="1413"/>
-              </a:spcAft>
-              <a:buSzPct val="75000"/>
-              <a:buFont typeface="StarSymbol"/>
-              <a:buChar char="●"/>
-              <a:defRPr sz="2400">
-                <a:solidFill>
-                  <a:srgbClr val="000000"/>
-                </a:solidFill>
-                <a:latin typeface="Times New Roman" pitchFamily="18" charset="0"/>
-                <a:ea typeface="Microsoft YaHei" pitchFamily="34" charset="-122"/>
-              </a:defRPr>
-            </a:lvl9pPr>
-          </a:lstStyle>
-          <a:p>
             <a:pPr algn="ctr" eaLnBrk="1">
               <a:spcAft>
                 <a:spcPct val="0"/>
@@ -13063,16 +13837,16 @@
               <a:buNone/>
             </a:pPr>
             <a:r>
-              <a:rPr lang="en-US" altLang="en-US" sz="3600">
+              <a:rPr lang="en-US" altLang="en-US" sz="3600" dirty="0">
                 <a:solidFill>
                   <a:srgbClr val="FFFFFF"/>
                 </a:solidFill>
                 <a:latin typeface="Tahoma" pitchFamily="34" charset="0"/>
                 <a:cs typeface="Tahoma" pitchFamily="34" charset="0"/>
               </a:rPr>
-              <a:t>Conclusion</a:t>
-            </a:r>
-            <a:endParaRPr lang="en-US" altLang="en-US" sz="2800">
+              <a:t>Quality Attributes (TODO 4)</a:t>
+            </a:r>
+            <a:endParaRPr lang="en-US" altLang="en-US" sz="2800" dirty="0">
               <a:solidFill>
                 <a:srgbClr val="FFFFFF"/>
               </a:solidFill>
@@ -13082,98 +13856,367 @@
           </a:p>
         </p:txBody>
       </p:sp>
+      <p:sp>
+        <p:nvSpPr>
+          <p:cNvPr id="3" name="TextBox 2">
+            <a:extLst>
+              <a:ext uri="{FF2B5EF4-FFF2-40B4-BE49-F238E27FC236}">
+                <a16:creationId xmlns:a16="http://schemas.microsoft.com/office/drawing/2014/main" id="{C6E6FDD9-2D49-799E-F950-4228F8EE3C46}"/>
+              </a:ext>
+            </a:extLst>
+          </p:cNvPr>
+          <p:cNvSpPr txBox="1"/>
+          <p:nvPr/>
+        </p:nvSpPr>
+        <p:spPr>
+          <a:xfrm>
+            <a:off x="303213" y="-1960095"/>
+            <a:ext cx="8662987" cy="7848302"/>
+          </a:xfrm>
+          <a:prstGeom prst="rect">
+            <a:avLst/>
+          </a:prstGeom>
+          <a:noFill/>
+        </p:spPr>
+        <p:txBody>
+          <a:bodyPr wrap="square">
+            <a:spAutoFit/>
+          </a:bodyPr>
+          <a:lstStyle/>
+          <a:p>
+            <a:pPr marL="342900" indent="-342900" algn="just" eaLnBrk="1">
+              <a:buFont typeface="+mj-lt"/>
+              <a:buAutoNum type="arabicPeriod"/>
+            </a:pPr>
+            <a:r>
+              <a:rPr lang="en-US" altLang="en-US" dirty="0" err="1">
+                <a:solidFill>
+                  <a:srgbClr val="1C1C1C"/>
+                </a:solidFill>
+                <a:latin typeface="Tahoma" pitchFamily="34" charset="0"/>
+                <a:cs typeface="Tahoma" pitchFamily="34" charset="0"/>
+              </a:rPr>
+              <a:t>Ç</a:t>
+            </a:r>
+            <a:endParaRPr lang="en-US" altLang="en-US" dirty="0">
+              <a:solidFill>
+                <a:srgbClr val="1C1C1C"/>
+              </a:solidFill>
+              <a:latin typeface="Tahoma" pitchFamily="34" charset="0"/>
+              <a:cs typeface="Tahoma" pitchFamily="34" charset="0"/>
+            </a:endParaRPr>
+          </a:p>
+          <a:p>
+            <a:pPr marL="342900" indent="-342900" algn="just" eaLnBrk="1">
+              <a:buFont typeface="+mj-lt"/>
+              <a:buAutoNum type="arabicPeriod"/>
+            </a:pPr>
+            <a:r>
+              <a:rPr lang="en-US" altLang="en-US" dirty="0">
+                <a:solidFill>
+                  <a:srgbClr val="1C1C1C"/>
+                </a:solidFill>
+                <a:latin typeface="Tahoma" pitchFamily="34" charset="0"/>
+                <a:cs typeface="Tahoma" pitchFamily="34" charset="0"/>
+              </a:rPr>
+              <a:t>P</a:t>
+            </a:r>
+          </a:p>
+          <a:p>
+            <a:pPr marL="342900" indent="-342900" algn="just" eaLnBrk="1">
+              <a:buFont typeface="+mj-lt"/>
+              <a:buAutoNum type="arabicPeriod"/>
+            </a:pPr>
+            <a:endParaRPr lang="en-US" altLang="en-US" dirty="0">
+              <a:solidFill>
+                <a:srgbClr val="1C1C1C"/>
+              </a:solidFill>
+              <a:latin typeface="Tahoma" pitchFamily="34" charset="0"/>
+              <a:cs typeface="Tahoma" pitchFamily="34" charset="0"/>
+            </a:endParaRPr>
+          </a:p>
+          <a:p>
+            <a:pPr marL="342900" indent="-342900" algn="just" eaLnBrk="1">
+              <a:buFont typeface="+mj-lt"/>
+              <a:buAutoNum type="arabicPeriod"/>
+            </a:pPr>
+            <a:endParaRPr lang="en-US" altLang="en-US" dirty="0">
+              <a:solidFill>
+                <a:srgbClr val="1C1C1C"/>
+              </a:solidFill>
+              <a:latin typeface="Tahoma" pitchFamily="34" charset="0"/>
+              <a:cs typeface="Tahoma" pitchFamily="34" charset="0"/>
+            </a:endParaRPr>
+          </a:p>
+          <a:p>
+            <a:pPr marL="342900" indent="-342900" algn="just" eaLnBrk="1">
+              <a:buFont typeface="+mj-lt"/>
+              <a:buAutoNum type="arabicPeriod"/>
+            </a:pPr>
+            <a:endParaRPr lang="en-US" altLang="en-US" dirty="0">
+              <a:solidFill>
+                <a:srgbClr val="1C1C1C"/>
+              </a:solidFill>
+              <a:latin typeface="Tahoma" pitchFamily="34" charset="0"/>
+              <a:cs typeface="Tahoma" pitchFamily="34" charset="0"/>
+            </a:endParaRPr>
+          </a:p>
+          <a:p>
+            <a:pPr marL="342900" indent="-342900" algn="just" eaLnBrk="1">
+              <a:buFont typeface="+mj-lt"/>
+              <a:buAutoNum type="arabicPeriod"/>
+            </a:pPr>
+            <a:endParaRPr lang="en-US" altLang="en-US" dirty="0">
+              <a:solidFill>
+                <a:srgbClr val="1C1C1C"/>
+              </a:solidFill>
+              <a:latin typeface="Tahoma" pitchFamily="34" charset="0"/>
+              <a:cs typeface="Tahoma" pitchFamily="34" charset="0"/>
+            </a:endParaRPr>
+          </a:p>
+          <a:p>
+            <a:pPr marL="342900" indent="-342900" algn="just" eaLnBrk="1">
+              <a:buFont typeface="+mj-lt"/>
+              <a:buAutoNum type="arabicPeriod"/>
+            </a:pPr>
+            <a:endParaRPr lang="en-US" altLang="en-US" dirty="0">
+              <a:solidFill>
+                <a:srgbClr val="1C1C1C"/>
+              </a:solidFill>
+              <a:latin typeface="Tahoma" pitchFamily="34" charset="0"/>
+              <a:cs typeface="Tahoma" pitchFamily="34" charset="0"/>
+            </a:endParaRPr>
+          </a:p>
+          <a:p>
+            <a:pPr marL="342900" indent="-342900" algn="just" eaLnBrk="1">
+              <a:buFont typeface="+mj-lt"/>
+              <a:buAutoNum type="arabicPeriod"/>
+            </a:pPr>
+            <a:endParaRPr lang="en-US" altLang="en-US" dirty="0">
+              <a:solidFill>
+                <a:srgbClr val="1C1C1C"/>
+              </a:solidFill>
+              <a:latin typeface="Tahoma" pitchFamily="34" charset="0"/>
+              <a:cs typeface="Tahoma" pitchFamily="34" charset="0"/>
+            </a:endParaRPr>
+          </a:p>
+          <a:p>
+            <a:pPr marL="342900" indent="-342900" algn="just" eaLnBrk="1">
+              <a:buFont typeface="+mj-lt"/>
+              <a:buAutoNum type="arabicPeriod"/>
+            </a:pPr>
+            <a:endParaRPr lang="en-US" altLang="en-US" dirty="0">
+              <a:solidFill>
+                <a:srgbClr val="1C1C1C"/>
+              </a:solidFill>
+              <a:latin typeface="Tahoma" pitchFamily="34" charset="0"/>
+              <a:cs typeface="Tahoma" pitchFamily="34" charset="0"/>
+            </a:endParaRPr>
+          </a:p>
+          <a:p>
+            <a:pPr marL="342900" indent="-342900" algn="just" eaLnBrk="1">
+              <a:buFont typeface="+mj-lt"/>
+              <a:buAutoNum type="arabicPeriod"/>
+            </a:pPr>
+            <a:endParaRPr lang="en-US" altLang="en-US" dirty="0">
+              <a:solidFill>
+                <a:srgbClr val="1C1C1C"/>
+              </a:solidFill>
+              <a:latin typeface="Tahoma" pitchFamily="34" charset="0"/>
+              <a:cs typeface="Tahoma" pitchFamily="34" charset="0"/>
+            </a:endParaRPr>
+          </a:p>
+          <a:p>
+            <a:pPr marL="342900" indent="-342900" algn="just" eaLnBrk="1">
+              <a:buFont typeface="+mj-lt"/>
+              <a:buAutoNum type="arabicPeriod"/>
+            </a:pPr>
+            <a:endParaRPr lang="en-US" altLang="en-US" dirty="0">
+              <a:solidFill>
+                <a:srgbClr val="1C1C1C"/>
+              </a:solidFill>
+              <a:latin typeface="Tahoma" pitchFamily="34" charset="0"/>
+              <a:cs typeface="Tahoma" pitchFamily="34" charset="0"/>
+            </a:endParaRPr>
+          </a:p>
+          <a:p>
+            <a:pPr marL="342900" indent="-342900" algn="just" eaLnBrk="1">
+              <a:buFont typeface="+mj-lt"/>
+              <a:buAutoNum type="arabicPeriod"/>
+            </a:pPr>
+            <a:r>
+              <a:rPr lang="en-US" altLang="en-US" dirty="0">
+                <a:solidFill>
+                  <a:srgbClr val="1C1C1C"/>
+                </a:solidFill>
+                <a:latin typeface="Tahoma" pitchFamily="34" charset="0"/>
+                <a:cs typeface="Tahoma" pitchFamily="34" charset="0"/>
+              </a:rPr>
+              <a:t>Explainability</a:t>
+            </a:r>
+          </a:p>
+          <a:p>
+            <a:pPr marL="800100" lvl="1" indent="-342900" algn="just" eaLnBrk="1">
+              <a:buFont typeface="Courier New" panose="02070309020205020404" pitchFamily="49" charset="0"/>
+              <a:buChar char="o"/>
+            </a:pPr>
+            <a:r>
+              <a:rPr lang="en-US" altLang="en-US" dirty="0">
+                <a:solidFill>
+                  <a:srgbClr val="1C1C1C"/>
+                </a:solidFill>
+                <a:latin typeface="Tahoma" pitchFamily="34" charset="0"/>
+                <a:cs typeface="Tahoma" pitchFamily="34" charset="0"/>
+              </a:rPr>
+              <a:t>Essential for transparency, traceability, justifiability, and credibility.</a:t>
+            </a:r>
+          </a:p>
+          <a:p>
+            <a:pPr marL="800100" lvl="1" indent="-342900" algn="just" eaLnBrk="1">
+              <a:buFont typeface="Courier New" panose="02070309020205020404" pitchFamily="49" charset="0"/>
+              <a:buChar char="o"/>
+            </a:pPr>
+            <a:r>
+              <a:rPr lang="en-US" altLang="en-US" dirty="0">
+                <a:solidFill>
+                  <a:srgbClr val="1C1C1C"/>
+                </a:solidFill>
+                <a:latin typeface="Tahoma" pitchFamily="34" charset="0"/>
+                <a:cs typeface="Tahoma" pitchFamily="34" charset="0"/>
+              </a:rPr>
+              <a:t>Readable and descriptive names are used for each fact and rule, allowing for clear understanding of the system’s reasoning during debug. Some explanations are also printed, and many do so </a:t>
+            </a:r>
+            <a:r>
+              <a:rPr lang="en-US" altLang="en-US">
+                <a:solidFill>
+                  <a:srgbClr val="1C1C1C"/>
+                </a:solidFill>
+                <a:latin typeface="Tahoma" pitchFamily="34" charset="0"/>
+                <a:cs typeface="Tahoma" pitchFamily="34" charset="0"/>
+              </a:rPr>
+              <a:t>through explanation facts.</a:t>
+            </a:r>
+            <a:endParaRPr lang="en-US" altLang="en-US" dirty="0">
+              <a:solidFill>
+                <a:srgbClr val="1C1C1C"/>
+              </a:solidFill>
+              <a:latin typeface="Tahoma" pitchFamily="34" charset="0"/>
+              <a:cs typeface="Tahoma" pitchFamily="34" charset="0"/>
+            </a:endParaRPr>
+          </a:p>
+          <a:p>
+            <a:pPr marL="800100" lvl="1" indent="-342900" algn="just" eaLnBrk="1">
+              <a:buFont typeface="Courier New" panose="02070309020205020404" pitchFamily="49" charset="0"/>
+              <a:buChar char="o"/>
+            </a:pPr>
+            <a:r>
+              <a:rPr lang="en-US" altLang="en-US" dirty="0">
+                <a:solidFill>
+                  <a:srgbClr val="1C1C1C"/>
+                </a:solidFill>
+                <a:latin typeface="Tahoma" pitchFamily="34" charset="0"/>
+                <a:cs typeface="Tahoma" pitchFamily="34" charset="0"/>
+              </a:rPr>
+              <a:t>Explainability is very helpful for users seeking to understand the expert system’s reasoning. Making the system explainable thus has a positive impact.</a:t>
+            </a:r>
+          </a:p>
+          <a:p>
+            <a:pPr marL="342900" indent="-342900" algn="just" eaLnBrk="1">
+              <a:buFont typeface="+mj-lt"/>
+              <a:buAutoNum type="arabicPeriod"/>
+            </a:pPr>
+            <a:r>
+              <a:rPr lang="en-US" altLang="en-US" dirty="0">
+                <a:solidFill>
+                  <a:srgbClr val="1C1C1C"/>
+                </a:solidFill>
+                <a:latin typeface="Tahoma" pitchFamily="34" charset="0"/>
+                <a:cs typeface="Tahoma" pitchFamily="34" charset="0"/>
+              </a:rPr>
+              <a:t>Modifiability</a:t>
+            </a:r>
+          </a:p>
+          <a:p>
+            <a:pPr marL="800100" lvl="1" indent="-342900" algn="just" eaLnBrk="1">
+              <a:buFont typeface="Courier New" panose="02070309020205020404" pitchFamily="49" charset="0"/>
+              <a:buChar char="o"/>
+            </a:pPr>
+            <a:r>
+              <a:rPr lang="en-US" altLang="en-US" dirty="0">
+                <a:solidFill>
+                  <a:srgbClr val="1C1C1C"/>
+                </a:solidFill>
+                <a:latin typeface="Tahoma" pitchFamily="34" charset="0"/>
+                <a:cs typeface="Tahoma" pitchFamily="34" charset="0"/>
+              </a:rPr>
+              <a:t>Important for long-term maintainability.</a:t>
+            </a:r>
+          </a:p>
+          <a:p>
+            <a:pPr marL="800100" lvl="1" indent="-342900" algn="just" eaLnBrk="1">
+              <a:buFont typeface="Courier New" panose="02070309020205020404" pitchFamily="49" charset="0"/>
+              <a:buChar char="o"/>
+            </a:pPr>
+            <a:r>
+              <a:rPr lang="en-US" altLang="en-US" dirty="0">
+                <a:solidFill>
+                  <a:srgbClr val="1C1C1C"/>
+                </a:solidFill>
+                <a:latin typeface="Tahoma" pitchFamily="34" charset="0"/>
+                <a:cs typeface="Tahoma" pitchFamily="34" charset="0"/>
+              </a:rPr>
+              <a:t>Ripple effects when making modifications are prevented: all input fact values can be modified in one place, the </a:t>
+            </a:r>
+            <a:r>
+              <a:rPr lang="en-US" altLang="en-US" dirty="0" err="1">
+                <a:solidFill>
+                  <a:srgbClr val="1C1C1C"/>
+                </a:solidFill>
+                <a:latin typeface="Tahoma" pitchFamily="34" charset="0"/>
+                <a:cs typeface="Tahoma" pitchFamily="34" charset="0"/>
+              </a:rPr>
+              <a:t>factbase</a:t>
+            </a:r>
+            <a:r>
+              <a:rPr lang="en-US" altLang="en-US" dirty="0">
+                <a:solidFill>
+                  <a:srgbClr val="1C1C1C"/>
+                </a:solidFill>
+                <a:latin typeface="Tahoma" pitchFamily="34" charset="0"/>
+                <a:cs typeface="Tahoma" pitchFamily="34" charset="0"/>
+              </a:rPr>
+              <a:t>. This makes the code quick and easy to modify. Salience is correctly used as a meta-rule to separate the setup, the reasoning, and the conclusion from each other.</a:t>
+            </a:r>
+          </a:p>
+          <a:p>
+            <a:pPr marL="800100" lvl="1" indent="-342900" algn="just" eaLnBrk="1">
+              <a:buFont typeface="Courier New" panose="02070309020205020404" pitchFamily="49" charset="0"/>
+              <a:buChar char="o"/>
+            </a:pPr>
+            <a:r>
+              <a:rPr lang="en-US" altLang="en-US" dirty="0">
+                <a:solidFill>
+                  <a:srgbClr val="1C1C1C"/>
+                </a:solidFill>
+                <a:latin typeface="Tahoma" pitchFamily="34" charset="0"/>
+                <a:cs typeface="Tahoma" pitchFamily="34" charset="0"/>
+              </a:rPr>
+              <a:t>Improving modifiability helps support a system’s long-term success, and is thus a positive force of the development process.</a:t>
+            </a:r>
+          </a:p>
+        </p:txBody>
+      </p:sp>
     </p:spTree>
+    <p:extLst>
+      <p:ext uri="{BB962C8B-B14F-4D97-AF65-F5344CB8AC3E}">
+        <p14:creationId xmlns:p14="http://schemas.microsoft.com/office/powerpoint/2010/main" val="1815365387"/>
+      </p:ext>
+    </p:extLst>
   </p:cSld>
   <p:clrMapOvr>
     <a:masterClrMapping/>
   </p:clrMapOvr>
   <p:transition spd="slow"/>
-  <p:timing>
-    <p:tnLst>
-      <p:par>
-        <p:cTn id="1" dur="indefinite" restart="never" nodeType="tmRoot">
-          <p:childTnLst>
-            <p:seq concurrent="1" nextAc="seek">
-              <p:cTn id="2" dur="indefinite" nodeType="mainSeq">
-                <p:childTnLst>
-                  <p:par>
-                    <p:cTn id="3" fill="hold" nodeType="clickPar">
-                      <p:stCondLst>
-                        <p:cond delay="indefinite"/>
-                      </p:stCondLst>
-                      <p:childTnLst>
-                        <p:par>
-                          <p:cTn id="4" fill="hold" nodeType="withGroup">
-                            <p:stCondLst>
-                              <p:cond delay="0"/>
-                            </p:stCondLst>
-                            <p:childTnLst>
-                              <p:par>
-                                <p:cTn id="5" presetID="4" presetClass="entr" presetSubtype="16" fill="hold" grpId="0" nodeType="clickEffect">
-                                  <p:stCondLst>
-                                    <p:cond delay="0"/>
-                                  </p:stCondLst>
-                                  <p:childTnLst>
-                                    <p:set>
-                                      <p:cBhvr>
-                                        <p:cTn id="6" dur="1" fill="hold">
-                                          <p:stCondLst>
-                                            <p:cond delay="0"/>
-                                          </p:stCondLst>
-                                        </p:cTn>
-                                        <p:tgtEl>
-                                          <p:spTgt spid="5"/>
-                                        </p:tgtEl>
-                                        <p:attrNameLst>
-                                          <p:attrName>style.visibility</p:attrName>
-                                        </p:attrNameLst>
-                                      </p:cBhvr>
-                                      <p:to>
-                                        <p:strVal val="visible"/>
-                                      </p:to>
-                                    </p:set>
-                                    <p:animEffect transition="in" filter="box(in)">
-                                      <p:cBhvr>
-                                        <p:cTn id="7" dur="500"/>
-                                        <p:tgtEl>
-                                          <p:spTgt spid="5"/>
-                                        </p:tgtEl>
-                                      </p:cBhvr>
-                                    </p:animEffect>
-                                  </p:childTnLst>
-                                </p:cTn>
-                              </p:par>
-                            </p:childTnLst>
-                          </p:cTn>
-                        </p:par>
-                      </p:childTnLst>
-                    </p:cTn>
-                  </p:par>
-                </p:childTnLst>
-              </p:cTn>
-              <p:prevCondLst>
-                <p:cond evt="onPrev" delay="0">
-                  <p:tgtEl>
-                    <p:sldTgt/>
-                  </p:tgtEl>
-                </p:cond>
-              </p:prevCondLst>
-              <p:nextCondLst>
-                <p:cond evt="onNext" delay="0">
-                  <p:tgtEl>
-                    <p:sldTgt/>
-                  </p:tgtEl>
-                </p:cond>
-              </p:nextCondLst>
-            </p:seq>
-          </p:childTnLst>
-        </p:cTn>
-      </p:par>
-    </p:tnLst>
-    <p:bldLst>
-      <p:bldP spid="5" grpId="0" autoUpdateAnimBg="0"/>
-    </p:bldLst>
-  </p:timing>
 </p:sld>
 </file>
 

</xml_diff>